<commit_message>
Refine UI and update project documentation
- Reduce font and menu sizes in Recorder Page quality selection.
- Ensure record list duration always uses 2-digit seconds.
- Hide remaining time and center elapsed time in Record Player.
- Update Jules_Improvements_Summary.pptx to a single slide summary.

Co-authored-by: MuhammetFevziBayiroglu <28693073+MuhammetFevziBayiroglu@users.noreply.github.com>
</commit_message>
<xml_diff>
--- a/Jules_Improvements_Summary.pptx
+++ b/Jules_Improvements_Summary.pptx
@@ -6,11 +6,6 @@
   </p:sldMasterIdLst>
   <p:sldIdLst>
     <p:sldId id="256" r:id="rId7"/>
-    <p:sldId id="257" r:id="rId8"/>
-    <p:sldId id="258" r:id="rId9"/>
-    <p:sldId id="259" r:id="rId10"/>
-    <p:sldId id="260" r:id="rId11"/>
-    <p:sldId id="261" r:id="rId12"/>
   </p:sldIdLst>
   <p:sldSz cx="9144000" cy="6858000" type="screen4x3"/>
   <p:notesSz cx="6858000" cy="9144000"/>
@@ -3095,467 +3090,127 @@
       <p:grpSpPr/>
       <p:sp>
         <p:nvSpPr>
-          <p:cNvPr id="2" name="Title 1"/>
-          <p:cNvSpPr>
-            <a:spLocks noGrp="1"/>
-          </p:cNvSpPr>
-          <p:nvPr>
-            <p:ph type="ctrTitle"/>
-          </p:nvPr>
-        </p:nvSpPr>
-        <p:spPr/>
-        <p:txBody>
-          <a:bodyPr/>
-          <a:lstStyle/>
-          <a:p>
-            <a:r>
-              <a:t>WVNotes Improvements Summary</a:t>
-            </a:r>
-          </a:p>
-        </p:txBody>
-      </p:sp>
-      <p:sp>
-        <p:nvSpPr>
-          <p:cNvPr id="3" name="Subtitle 2"/>
-          <p:cNvSpPr>
-            <a:spLocks noGrp="1"/>
-          </p:cNvSpPr>
-          <p:nvPr>
-            <p:ph type="subTitle" idx="1"/>
-          </p:nvPr>
-        </p:nvSpPr>
-        <p:spPr/>
-        <p:txBody>
-          <a:bodyPr/>
-          <a:lstStyle/>
-          <a:p>
-            <a:r>
-              <a:t>Enhancements for Audio Player, Recorder, and Watch UI</a:t>
-            </a:r>
-          </a:p>
-          <a:p>
-            <a:r>
-              <a:t>By Jules</a:t>
-            </a:r>
-          </a:p>
-        </p:txBody>
-      </p:sp>
-    </p:spTree>
-  </p:cSld>
-  <p:clrMapOvr>
-    <a:masterClrMapping/>
-  </p:clrMapOvr>
-</p:sld>
-</file>
-
-<file path=ppt/slides/slide2.xml><?xml version="1.0" encoding="utf-8"?>
-<p:sld xmlns:a="http://schemas.openxmlformats.org/drawingml/2006/main" xmlns:p="http://schemas.openxmlformats.org/presentationml/2006/main" xmlns:r="http://schemas.openxmlformats.org/officeDocument/2006/relationships">
-  <p:cSld>
-    <p:spTree>
-      <p:nvGrpSpPr>
-        <p:cNvPr id="1" name=""/>
-        <p:cNvGrpSpPr/>
-        <p:nvPr/>
-      </p:nvGrpSpPr>
-      <p:grpSpPr/>
-      <p:sp>
-        <p:nvSpPr>
-          <p:cNvPr id="2" name="Title 1"/>
-          <p:cNvSpPr>
-            <a:spLocks noGrp="1"/>
-          </p:cNvSpPr>
-          <p:nvPr>
-            <p:ph type="title"/>
-          </p:nvPr>
-        </p:nvSpPr>
-        <p:spPr/>
-        <p:txBody>
-          <a:bodyPr/>
-          <a:lstStyle/>
-          <a:p>
-            <a:r>
-              <a:t>Audio Player Enhancements</a:t>
-            </a:r>
-          </a:p>
-        </p:txBody>
-      </p:sp>
-      <p:sp>
-        <p:nvSpPr>
-          <p:cNvPr id="3" name="Content Placeholder 2"/>
-          <p:cNvSpPr>
-            <a:spLocks noGrp="1"/>
-          </p:cNvSpPr>
-          <p:nvPr>
-            <p:ph idx="1"/>
-          </p:nvPr>
-        </p:nvSpPr>
-        <p:spPr/>
-        <p:txBody>
-          <a:bodyPr/>
-          <a:lstStyle/>
-          <a:p>
-            <a:r>
-              <a:t>Interactive &amp; User-Friendly Controls</a:t>
-            </a:r>
-          </a:p>
-          <a:p>
-            <a:pPr lvl="1"/>
-            <a:r>
-              <a:t>Reactive progress slider (Slider) for precise seeking</a:t>
-            </a:r>
-          </a:p>
-          <a:p>
-            <a:pPr lvl="1"/>
-            <a:r>
-              <a:t>Real-time current time and remaining time displays</a:t>
-            </a:r>
-          </a:p>
-          <a:p>
-            <a:pPr lvl="1"/>
-            <a:r>
-              <a:t>10s skip buttons (backward/forward) for quick navigation</a:t>
-            </a:r>
-          </a:p>
-          <a:p>
-            <a:pPr lvl="1"/>
-            <a:r>
-              <a:t>Playback speed selector (0.5x, 1.0x, 2.0x)</a:t>
-            </a:r>
-          </a:p>
-          <a:p>
-            <a:pPr lvl="1"/>
-            <a:r>
-              <a:t>Auto-play next record logic in Notes list</a:t>
-            </a:r>
-          </a:p>
-        </p:txBody>
-      </p:sp>
-    </p:spTree>
-  </p:cSld>
-  <p:clrMapOvr>
-    <a:masterClrMapping/>
-  </p:clrMapOvr>
-</p:sld>
-</file>
-
-<file path=ppt/slides/slide3.xml><?xml version="1.0" encoding="utf-8"?>
-<p:sld xmlns:a="http://schemas.openxmlformats.org/drawingml/2006/main" xmlns:p="http://schemas.openxmlformats.org/presentationml/2006/main" xmlns:r="http://schemas.openxmlformats.org/officeDocument/2006/relationships">
-  <p:cSld>
-    <p:spTree>
-      <p:nvGrpSpPr>
-        <p:cNvPr id="1" name=""/>
-        <p:cNvGrpSpPr/>
-        <p:nvPr/>
-      </p:nvGrpSpPr>
-      <p:grpSpPr/>
-      <p:sp>
-        <p:nvSpPr>
-          <p:cNvPr id="2" name="Title 1"/>
-          <p:cNvSpPr>
-            <a:spLocks noGrp="1"/>
-          </p:cNvSpPr>
-          <p:nvPr>
-            <p:ph type="title"/>
-          </p:nvPr>
-        </p:nvSpPr>
-        <p:spPr/>
-        <p:txBody>
-          <a:bodyPr/>
-          <a:lstStyle/>
-          <a:p>
-            <a:r>
-              <a:t>Audio Recorder Enhancements</a:t>
-            </a:r>
-          </a:p>
-        </p:txBody>
-      </p:sp>
-      <p:sp>
-        <p:nvSpPr>
-          <p:cNvPr id="3" name="Content Placeholder 2"/>
-          <p:cNvSpPr>
-            <a:spLocks noGrp="1"/>
-          </p:cNvSpPr>
-          <p:nvPr>
-            <p:ph idx="1"/>
-          </p:nvPr>
-        </p:nvSpPr>
-        <p:spPr/>
-        <p:txBody>
-          <a:bodyPr/>
-          <a:lstStyle/>
-          <a:p>
-            <a:r>
-              <a:t>Advanced Recording Features</a:t>
-            </a:r>
-          </a:p>
-          <a:p>
-            <a:pPr lvl="1"/>
-            <a:r>
-              <a:t>Added Pause and Resume functionality during recording</a:t>
-            </a:r>
-          </a:p>
-          <a:p>
-            <a:pPr lvl="1"/>
-            <a:r>
-              <a:t>Configurable Quality settings (Low, Average, High)</a:t>
-            </a:r>
-          </a:p>
-          <a:p>
-            <a:pPr lvl="1"/>
-            <a:r>
-              <a:t>Optional maximum record time limit (seconds)</a:t>
-            </a:r>
-          </a:p>
-          <a:p>
-            <a:pPr lvl="1"/>
-            <a:r>
-              <a:t>Real-time elapsed time display</a:t>
-            </a:r>
-          </a:p>
-        </p:txBody>
-      </p:sp>
-    </p:spTree>
-  </p:cSld>
-  <p:clrMapOvr>
-    <a:masterClrMapping/>
-  </p:clrMapOvr>
-</p:sld>
-</file>
-
-<file path=ppt/slides/slide4.xml><?xml version="1.0" encoding="utf-8"?>
-<p:sld xmlns:a="http://schemas.openxmlformats.org/drawingml/2006/main" xmlns:p="http://schemas.openxmlformats.org/presentationml/2006/main" xmlns:r="http://schemas.openxmlformats.org/officeDocument/2006/relationships">
-  <p:cSld>
-    <p:spTree>
-      <p:nvGrpSpPr>
-        <p:cNvPr id="1" name=""/>
-        <p:cNvGrpSpPr/>
-        <p:nvPr/>
-      </p:nvGrpSpPr>
-      <p:grpSpPr/>
-      <p:sp>
-        <p:nvSpPr>
-          <p:cNvPr id="2" name="Title 1"/>
-          <p:cNvSpPr>
-            <a:spLocks noGrp="1"/>
-          </p:cNvSpPr>
-          <p:nvPr>
-            <p:ph type="title"/>
-          </p:nvPr>
-        </p:nvSpPr>
-        <p:spPr/>
-        <p:txBody>
-          <a:bodyPr/>
-          <a:lstStyle/>
-          <a:p>
-            <a:r>
-              <a:t>Watch UI/UX Optimization</a:t>
-            </a:r>
-          </a:p>
-        </p:txBody>
-      </p:sp>
-      <p:sp>
-        <p:nvSpPr>
-          <p:cNvPr id="3" name="Content Placeholder 2"/>
-          <p:cNvSpPr>
-            <a:spLocks noGrp="1"/>
-          </p:cNvSpPr>
-          <p:nvPr>
-            <p:ph idx="1"/>
-          </p:nvPr>
-        </p:nvSpPr>
-        <p:spPr/>
-        <p:txBody>
-          <a:bodyPr/>
-          <a:lstStyle/>
-          <a:p>
-            <a:r>
-              <a:t>Optimized for Small Screen Real Estate</a:t>
-            </a:r>
-          </a:p>
-          <a:p>
-            <a:pPr lvl="1"/>
-            <a:r>
-              <a:t>Reduced component widths (e.g., 60% for player) to avoid bezel clipping</a:t>
-            </a:r>
-          </a:p>
-          <a:p>
-            <a:pPr lvl="1"/>
-            <a:r>
-              <a:t>Vertically centered layouts for circular watch faces</a:t>
-            </a:r>
-          </a:p>
-          <a:p>
-            <a:pPr lvl="1"/>
-            <a:r>
-              <a:t>Integrated HarmonyOS system symbol glyphs for clarity</a:t>
-            </a:r>
-          </a:p>
-          <a:p>
-            <a:pPr lvl="1"/>
-            <a:r>
-              <a:t>Optimized font sizes (10-12fp) for wearable display</a:t>
-            </a:r>
-          </a:p>
-        </p:txBody>
-      </p:sp>
-    </p:spTree>
-  </p:cSld>
-  <p:clrMapOvr>
-    <a:masterClrMapping/>
-  </p:clrMapOvr>
-</p:sld>
-</file>
-
-<file path=ppt/slides/slide5.xml><?xml version="1.0" encoding="utf-8"?>
-<p:sld xmlns:a="http://schemas.openxmlformats.org/drawingml/2006/main" xmlns:p="http://schemas.openxmlformats.org/presentationml/2006/main" xmlns:r="http://schemas.openxmlformats.org/officeDocument/2006/relationships">
-  <p:cSld>
-    <p:spTree>
-      <p:nvGrpSpPr>
-        <p:cNvPr id="1" name=""/>
-        <p:cNvGrpSpPr/>
-        <p:nvPr/>
-      </p:nvGrpSpPr>
-      <p:grpSpPr/>
-      <p:sp>
-        <p:nvSpPr>
-          <p:cNvPr id="2" name="Title 1"/>
-          <p:cNvSpPr>
-            <a:spLocks noGrp="1"/>
-          </p:cNvSpPr>
-          <p:nvPr>
-            <p:ph type="title"/>
-          </p:nvPr>
-        </p:nvSpPr>
-        <p:spPr/>
-        <p:txBody>
-          <a:bodyPr/>
-          <a:lstStyle/>
-          <a:p>
-            <a:r>
-              <a:t>Notes List Enhancements</a:t>
-            </a:r>
-          </a:p>
-        </p:txBody>
-      </p:sp>
-      <p:sp>
-        <p:nvSpPr>
-          <p:cNvPr id="3" name="Content Placeholder 2"/>
-          <p:cNvSpPr>
-            <a:spLocks noGrp="1"/>
-          </p:cNvSpPr>
-          <p:nvPr>
-            <p:ph idx="1"/>
-          </p:nvPr>
-        </p:nvSpPr>
-        <p:spPr/>
-        <p:txBody>
-          <a:bodyPr/>
-          <a:lstStyle/>
-          <a:p>
-            <a:r>
-              <a:t>Improved Record Management</a:t>
-            </a:r>
-          </a:p>
-          <a:p>
-            <a:pPr lvl="1"/>
-            <a:r>
-              <a:t>Human-readable file size display (B, KB, MB)</a:t>
-            </a:r>
-          </a:p>
-          <a:p>
-            <a:pPr lvl="1"/>
-            <a:r>
-              <a:t>24-hour date/time formatting for record names</a:t>
-            </a:r>
-          </a:p>
-          <a:p>
-            <a:pPr lvl="1"/>
-            <a:r>
-              <a:t>Multi-selection mode via LongPress gesture</a:t>
-            </a:r>
-          </a:p>
-          <a:p>
-            <a:pPr lvl="1"/>
-            <a:r>
-              <a:t>Batch delete and single-record rename in selection mode</a:t>
-            </a:r>
-          </a:p>
-        </p:txBody>
-      </p:sp>
-    </p:spTree>
-  </p:cSld>
-  <p:clrMapOvr>
-    <a:masterClrMapping/>
-  </p:clrMapOvr>
-</p:sld>
-</file>
-
-<file path=ppt/slides/slide6.xml><?xml version="1.0" encoding="utf-8"?>
-<p:sld xmlns:a="http://schemas.openxmlformats.org/drawingml/2006/main" xmlns:p="http://schemas.openxmlformats.org/presentationml/2006/main" xmlns:r="http://schemas.openxmlformats.org/officeDocument/2006/relationships">
-  <p:cSld>
-    <p:spTree>
-      <p:nvGrpSpPr>
-        <p:cNvPr id="1" name=""/>
-        <p:cNvGrpSpPr/>
-        <p:nvPr/>
-      </p:nvGrpSpPr>
-      <p:grpSpPr/>
-      <p:sp>
-        <p:nvSpPr>
-          <p:cNvPr id="2" name="Title 1"/>
-          <p:cNvSpPr>
-            <a:spLocks noGrp="1"/>
-          </p:cNvSpPr>
-          <p:nvPr>
-            <p:ph type="title"/>
-          </p:nvPr>
-        </p:nvSpPr>
-        <p:spPr/>
-        <p:txBody>
-          <a:bodyPr/>
-          <a:lstStyle/>
-          <a:p>
-            <a:r>
-              <a:t>Technical Optimizations</a:t>
-            </a:r>
-          </a:p>
-        </p:txBody>
-      </p:sp>
-      <p:sp>
-        <p:nvSpPr>
-          <p:cNvPr id="3" name="Content Placeholder 2"/>
-          <p:cNvSpPr>
-            <a:spLocks noGrp="1"/>
-          </p:cNvSpPr>
-          <p:nvPr>
-            <p:ph idx="1"/>
-          </p:nvPr>
-        </p:nvSpPr>
-        <p:spPr/>
-        <p:txBody>
-          <a:bodyPr/>
-          <a:lstStyle/>
-          <a:p>
-            <a:r>
-              <a:t>Stability and Reactivity</a:t>
-            </a:r>
-          </a:p>
-          <a:p>
-            <a:pPr lvl="1"/>
-            <a:r>
-              <a:t>Fixed ArkUI reactivity using @Observed and @ObjectLink</a:t>
-            </a:r>
-          </a:p>
-          <a:p>
-            <a:pPr lvl="1"/>
-            <a:r>
-              <a:t>Optimized seeking with media.SeekMode.SEEK_PREV_SYNC</a:t>
-            </a:r>
-          </a:p>
-          <a:p>
-            <a:pPr lvl="1"/>
-            <a:r>
-              <a:t>Asynchronous duration fetching using AVMetadataExtractor</a:t>
+          <p:cNvPr id="2" name="TextBox 1"/>
+          <p:cNvSpPr txBox="1"/>
+          <p:nvPr/>
+        </p:nvSpPr>
+        <p:spPr>
+          <a:xfrm>
+            <a:off x="457200" y="182880"/>
+            <a:ext cx="8229600" cy="914400"/>
+          </a:xfrm>
+          <a:prstGeom prst="rect">
+            <a:avLst/>
+          </a:prstGeom>
+          <a:noFill/>
+        </p:spPr>
+        <p:txBody>
+          <a:bodyPr wrap="none">
+            <a:spAutoFit/>
+          </a:bodyPr>
+          <a:lstStyle/>
+          <a:p>
+            <a:pPr>
+              <a:defRPr b="1" sz="3200"/>
+            </a:pPr>
+            <a:r>
+              <a:t>Project Improvements Summary</a:t>
+            </a:r>
+          </a:p>
+        </p:txBody>
+      </p:sp>
+      <p:sp>
+        <p:nvSpPr>
+          <p:cNvPr id="3" name="TextBox 2"/>
+          <p:cNvSpPr txBox="1"/>
+          <p:nvPr/>
+        </p:nvSpPr>
+        <p:spPr>
+          <a:xfrm>
+            <a:off x="457200" y="1097280"/>
+            <a:ext cx="8229600" cy="5486400"/>
+          </a:xfrm>
+          <a:prstGeom prst="rect">
+            <a:avLst/>
+          </a:prstGeom>
+          <a:noFill/>
+        </p:spPr>
+        <p:txBody>
+          <a:bodyPr wrap="square">
+            <a:spAutoFit/>
+          </a:bodyPr>
+          <a:lstStyle/>
+          <a:p/>
+          <a:p>
+            <a:pPr>
+              <a:defRPr b="1" sz="2400"/>
+            </a:pPr>
+            <a:r>
+              <a:t>Record Management Abilities</a:t>
+            </a:r>
+          </a:p>
+          <a:p>
+            <a:pPr lvl="1">
+              <a:defRPr sz="1800"/>
+            </a:pPr>
+            <a:r>
+              <a:t>- Implemented record renaming and deletion functionality.</a:t>
+            </a:r>
+          </a:p>
+          <a:p>
+            <a:pPr lvl="1">
+              <a:defRPr sz="1800"/>
+            </a:pPr>
+            <a:r>
+              <a:t>- Added batch deletion support in selection mode.</a:t>
+            </a:r>
+          </a:p>
+          <a:p>
+            <a:pPr>
+              <a:defRPr b="1" sz="2400"/>
+            </a:pPr>
+            <a:r>
+              <a:t>Player Control Improvements</a:t>
+            </a:r>
+          </a:p>
+          <a:p>
+            <a:pPr lvl="1">
+              <a:defRPr sz="1800"/>
+            </a:pPr>
+            <a:r>
+              <a:t>- Refined UI by showing only elapsed time for better clarity.</a:t>
+            </a:r>
+          </a:p>
+          <a:p>
+            <a:pPr lvl="1">
+              <a:defRPr sz="1800"/>
+            </a:pPr>
+            <a:r>
+              <a:t>- Improved seeking and playback speed controls.</a:t>
+            </a:r>
+          </a:p>
+          <a:p>
+            <a:pPr>
+              <a:defRPr b="1" sz="2400"/>
+            </a:pPr>
+            <a:r>
+              <a:t>Audio Recording Improvements</a:t>
+            </a:r>
+          </a:p>
+          <a:p>
+            <a:pPr lvl="1">
+              <a:defRPr sz="1800"/>
+            </a:pPr>
+            <a:r>
+              <a:t>- Optimized recording quality selection UI with reduced font and menu sizes.</a:t>
+            </a:r>
+          </a:p>
+          <a:p>
+            <a:pPr lvl="1">
+              <a:defRPr sz="1800"/>
+            </a:pPr>
+            <a:r>
+              <a:t>- Fixed duration formatting to ensure consistent 2-digit seconds display.</a:t>
             </a:r>
           </a:p>
         </p:txBody>

</xml_diff>